<commit_message>
v2: use version 1 photo placement and crops, drop bottom logo after title
Co-Authored-By: Claude Opus 5.5 <noreply@anthropic.com>
Claude-Session: https://claude.ai/code/session_016Ce846Uwi4MoBmUSJew8t7
</commit_message>
<xml_diff>
--- a/presentation/Noo_community_v2.pptx
+++ b/presentation/Noo_community_v2.pptx
@@ -3138,7 +3138,7 @@
       <p:grpSpPr/>
       <p:pic>
         <p:nvPicPr>
-          <p:cNvPr id="2" name="Picture 1" descr="bg_plain.png"/>
+          <p:cNvPr id="2" name="Picture 1" descr="bg_solid.png"/>
           <p:cNvPicPr>
             <a:picLocks noChangeAspect="1"/>
           </p:cNvPicPr>
@@ -3170,15 +3170,15 @@
         </p:nvPicPr>
         <p:blipFill>
           <a:blip r:embed="rId3"/>
-          <a:srcRect l="19556" r="26486" t="9356" b="39441"/>
+          <a:srcRect l="24023" r="30954" t="9356" b="39441"/>
           <a:stretch>
             <a:fillRect/>
           </a:stretch>
         </p:blipFill>
         <p:spPr>
           <a:xfrm>
-            <a:off x="13372252" y="822960"/>
-            <a:ext cx="5908886" cy="8412480"/>
+            <a:off x="13475884" y="0"/>
+            <a:ext cx="6628214" cy="11309350"/>
           </a:xfrm>
           <a:prstGeom prst="rect">
             <a:avLst/>
@@ -3205,7 +3205,7 @@
       <p:grpSpPr/>
       <p:pic>
         <p:nvPicPr>
-          <p:cNvPr id="2" name="Picture 1" descr="bg_plain.png"/>
+          <p:cNvPr id="2" name="Picture 1" descr="bg_solid.png"/>
           <p:cNvPicPr>
             <a:picLocks noChangeAspect="1"/>
           </p:cNvPicPr>
@@ -3237,15 +3237,15 @@
         </p:nvPicPr>
         <p:blipFill>
           <a:blip r:embed="rId3"/>
-          <a:srcRect l="19556" r="26486" t="9356" b="39441"/>
+          <a:srcRect l="24023" r="30954" t="9356" b="39441"/>
           <a:stretch>
             <a:fillRect/>
           </a:stretch>
         </p:blipFill>
         <p:spPr>
           <a:xfrm>
-            <a:off x="13372252" y="822960"/>
-            <a:ext cx="5908886" cy="8412480"/>
+            <a:off x="13475884" y="0"/>
+            <a:ext cx="6628214" cy="11309350"/>
           </a:xfrm>
           <a:prstGeom prst="rect">
             <a:avLst/>
@@ -3262,15 +3262,15 @@
         </p:nvPicPr>
         <p:blipFill>
           <a:blip r:embed="rId4"/>
-          <a:srcRect l="23263" r="18460" b="17031"/>
+          <a:srcRect l="28088" r="23285" b="17031"/>
           <a:stretch>
             <a:fillRect/>
           </a:stretch>
         </p:blipFill>
         <p:spPr>
           <a:xfrm>
-            <a:off x="822960" y="822960"/>
-            <a:ext cx="5908886" cy="8412480"/>
+            <a:off x="0" y="0"/>
+            <a:ext cx="6628214" cy="11309350"/>
           </a:xfrm>
           <a:prstGeom prst="rect">
             <a:avLst/>
@@ -3297,7 +3297,7 @@
       <p:grpSpPr/>
       <p:pic>
         <p:nvPicPr>
-          <p:cNvPr id="2" name="Picture 1" descr="bg_plain.png"/>
+          <p:cNvPr id="2" name="Picture 1" descr="bg_solid.png"/>
           <p:cNvPicPr>
             <a:picLocks noChangeAspect="1"/>
           </p:cNvPicPr>
@@ -3329,15 +3329,15 @@
         </p:nvPicPr>
         <p:blipFill>
           <a:blip r:embed="rId3"/>
-          <a:srcRect l="23263" r="18460" b="17031"/>
+          <a:srcRect l="28088" r="23285" b="17031"/>
           <a:stretch>
             <a:fillRect/>
           </a:stretch>
         </p:blipFill>
         <p:spPr>
           <a:xfrm>
-            <a:off x="822960" y="822960"/>
-            <a:ext cx="5908886" cy="8412480"/>
+            <a:off x="0" y="0"/>
+            <a:ext cx="6628214" cy="11309350"/>
           </a:xfrm>
           <a:prstGeom prst="rect">
             <a:avLst/>
@@ -3354,15 +3354,15 @@
         </p:nvPicPr>
         <p:blipFill>
           <a:blip r:embed="rId4"/>
-          <a:srcRect l="19556" r="26486" t="9356" b="39441"/>
+          <a:srcRect l="24023" r="30954" t="9356" b="39441"/>
           <a:stretch>
             <a:fillRect/>
           </a:stretch>
         </p:blipFill>
         <p:spPr>
           <a:xfrm>
-            <a:off x="13372252" y="822960"/>
-            <a:ext cx="5908886" cy="8412480"/>
+            <a:off x="13475884" y="0"/>
+            <a:ext cx="6628214" cy="11309350"/>
           </a:xfrm>
           <a:prstGeom prst="rect">
             <a:avLst/>
@@ -3379,15 +3379,15 @@
         </p:nvPicPr>
         <p:blipFill>
           <a:blip r:embed="rId5"/>
-          <a:srcRect l="51468" r="10135" t="17600" b="400"/>
+          <a:srcRect l="54647" r="13314" t="17600" b="400"/>
           <a:stretch>
             <a:fillRect/>
           </a:stretch>
         </p:blipFill>
         <p:spPr>
           <a:xfrm>
-            <a:off x="7097606" y="822960"/>
-            <a:ext cx="5908886" cy="8412480"/>
+            <a:off x="6737942" y="0"/>
+            <a:ext cx="6628214" cy="11309350"/>
           </a:xfrm>
           <a:prstGeom prst="rect">
             <a:avLst/>
@@ -3414,7 +3414,7 @@
       <p:grpSpPr/>
       <p:pic>
         <p:nvPicPr>
-          <p:cNvPr id="2" name="Picture 1" descr="bg_plain.png"/>
+          <p:cNvPr id="2" name="Picture 1" descr="bg_solid.png"/>
           <p:cNvPicPr>
             <a:picLocks noChangeAspect="1"/>
           </p:cNvPicPr>
@@ -3446,14 +3446,15 @@
         </p:nvPicPr>
         <p:blipFill>
           <a:blip r:embed="rId3"/>
+          <a:srcRect/>
           <a:stretch>
             <a:fillRect/>
           </a:stretch>
         </p:blipFill>
         <p:spPr>
           <a:xfrm>
-            <a:off x="1273810" y="822960"/>
-            <a:ext cx="8412480" cy="8412480"/>
+            <a:off x="0" y="0"/>
+            <a:ext cx="11309350" cy="11309350"/>
           </a:xfrm>
           <a:prstGeom prst="rect">
             <a:avLst/>
@@ -3468,8 +3469,8 @@
         </p:nvSpPr>
         <p:spPr>
           <a:xfrm>
-            <a:off x="10417810" y="822960"/>
-            <a:ext cx="8863330" cy="1280160"/>
+            <a:off x="11309350" y="320675"/>
+            <a:ext cx="8794750" cy="700000"/>
           </a:xfrm>
           <a:prstGeom prst="rect">
             <a:avLst/>
@@ -3484,7 +3485,7 @@
           <a:p>
             <a:pPr algn="ctr"/>
             <a:r>
-              <a:rPr sz="4000">
+              <a:rPr sz="3200">
                 <a:solidFill>
                   <a:srgbClr val="CACACA"/>
                 </a:solidFill>
@@ -3511,8 +3512,8 @@
         </p:blipFill>
         <p:spPr>
           <a:xfrm>
-            <a:off x="12014835" y="2834640"/>
-            <a:ext cx="5669280" cy="5669280"/>
+            <a:off x="12520011" y="2440785"/>
+            <a:ext cx="6373427" cy="6373427"/>
           </a:xfrm>
           <a:prstGeom prst="rect">
             <a:avLst/>
@@ -3539,7 +3540,7 @@
       <p:grpSpPr/>
       <p:pic>
         <p:nvPicPr>
-          <p:cNvPr id="2" name="Picture 1" descr="bg_plain.png"/>
+          <p:cNvPr id="2" name="Picture 1" descr="bg_solid.png"/>
           <p:cNvPicPr>
             <a:picLocks noChangeAspect="1"/>
           </p:cNvPicPr>
@@ -3571,14 +3572,15 @@
         </p:nvPicPr>
         <p:blipFill>
           <a:blip r:embed="rId3"/>
+          <a:srcRect b="15663"/>
           <a:stretch>
             <a:fillRect/>
           </a:stretch>
         </p:blipFill>
         <p:spPr>
           <a:xfrm>
-            <a:off x="3745941" y="822960"/>
-            <a:ext cx="12612218" cy="8412480"/>
+            <a:off x="0" y="0"/>
+            <a:ext cx="20104100" cy="11309350"/>
           </a:xfrm>
           <a:prstGeom prst="rect">
             <a:avLst/>
@@ -3605,7 +3607,7 @@
       <p:grpSpPr/>
       <p:pic>
         <p:nvPicPr>
-          <p:cNvPr id="2" name="Picture 1" descr="bg_arc.png"/>
+          <p:cNvPr id="2" name="Picture 1" descr="bg_final.png"/>
           <p:cNvPicPr>
             <a:picLocks noChangeAspect="1"/>
           </p:cNvPicPr>

</xml_diff>